<commit_message>
Portfolio: stages read problem to build to result, a number replaces runner-up, late-2026 channel targets, five-column origin rail, new container photo and eBay trio, no record codes, burst no longer stretches the page, jump button works in the record view; org chart v7
Co-Authored-By: Claude Fable 5.1 <noreply@anthropic.com>
Claude-Session: https://claude.ai/code/session_01JcAmtPULFCnwMNNoCwcZpd
</commit_message>
<xml_diff>
--- a/application/org-chart/FFSL-Organisational-Structure-Sept-2026.pptx
+++ b/application/org-chart/FFSL-Organisational-Structure-Sept-2026.pptx
@@ -6602,7 +6602,7 @@
           </a:solidFill>
           <a:ln w="6350">
             <a:solidFill>
-              <a:srgbClr val="111111"/>
+              <a:srgbClr val="8A8A85"/>
             </a:solidFill>
           </a:ln>
           <a:effectLst/>
@@ -6636,11 +6636,11 @@
             <a:r>
               <a:rPr sz="550" b="1">
                 <a:solidFill>
-                  <a:srgbClr val="111111"/>
+                  <a:srgbClr val="4B4B47"/>
                 </a:solidFill>
                 <a:latin typeface="Segoe UI"/>
               </a:rPr>
-              <a:t>Subcontractor</a:t>
+              <a:t>Volunteer</a:t>
             </a:r>
           </a:p>
         </p:txBody>
@@ -7107,13 +7107,77 @@
       </p:sp>
       <p:sp>
         <p:nvSpPr>
-          <p:cNvPr id="71" name="Rectangle 70"/>
+          <p:cNvPr id="71" name="Rounded Rectangle 70"/>
           <p:cNvSpPr/>
           <p:nvPr/>
         </p:nvSpPr>
         <p:spPr>
           <a:xfrm>
-            <a:off x="3063239" y="6775704"/>
+            <a:off x="2990087" y="6775704"/>
+            <a:ext cx="676656" cy="146304"/>
+          </a:xfrm>
+          <a:prstGeom prst="roundRect">
+            <a:avLst>
+              <a:gd name="adj" fmla="val 50000"/>
+            </a:avLst>
+          </a:prstGeom>
+          <a:solidFill>
+            <a:srgbClr val="FFFFFF"/>
+          </a:solidFill>
+          <a:ln w="6350">
+            <a:solidFill>
+              <a:srgbClr val="8A8A85"/>
+            </a:solidFill>
+          </a:ln>
+          <a:effectLst/>
+        </p:spPr>
+        <p:style>
+          <a:lnRef idx="1">
+            <a:schemeClr val="accent1"/>
+          </a:lnRef>
+          <a:fillRef idx="3">
+            <a:schemeClr val="accent1"/>
+          </a:fillRef>
+          <a:effectRef idx="2">
+            <a:schemeClr val="accent1"/>
+          </a:effectRef>
+          <a:fontRef idx="minor">
+            <a:schemeClr val="lt1"/>
+          </a:fontRef>
+        </p:style>
+        <p:txBody>
+          <a:bodyPr rtlCol="0" anchor="ctr" lIns="18288" rIns="18288" tIns="0" bIns="0" wrap="square"/>
+          <a:lstStyle/>
+          <a:p>
+            <a:pPr algn="ctr">
+              <a:spcBef>
+                <a:spcPts val="0"/>
+              </a:spcBef>
+              <a:spcAft>
+                <a:spcPts val="0"/>
+              </a:spcAft>
+            </a:pPr>
+            <a:r>
+              <a:rPr sz="550" b="1">
+                <a:solidFill>
+                  <a:srgbClr val="4B4B47"/>
+                </a:solidFill>
+                <a:latin typeface="Segoe UI"/>
+              </a:rPr>
+              <a:t>Volunteer</a:t>
+            </a:r>
+          </a:p>
+        </p:txBody>
+      </p:sp>
+      <p:sp>
+        <p:nvSpPr>
+          <p:cNvPr id="72" name="Rectangle 71"/>
+          <p:cNvSpPr/>
+          <p:nvPr/>
+        </p:nvSpPr>
+        <p:spPr>
+          <a:xfrm>
+            <a:off x="3794759" y="6775704"/>
             <a:ext cx="45720" cy="146304"/>
           </a:xfrm>
           <a:prstGeom prst="rect">
@@ -7151,13 +7215,13 @@
       </p:sp>
       <p:sp>
         <p:nvSpPr>
-          <p:cNvPr id="72" name="Rectangle 71"/>
+          <p:cNvPr id="73" name="Rectangle 72"/>
           <p:cNvSpPr/>
           <p:nvPr/>
         </p:nvSpPr>
         <p:spPr>
           <a:xfrm>
-            <a:off x="3118103" y="6748272"/>
+            <a:off x="3849623" y="6748272"/>
             <a:ext cx="3291840" cy="219456"/>
           </a:xfrm>
           <a:prstGeom prst="rect">
@@ -7209,7 +7273,7 @@
       </p:sp>
       <p:sp>
         <p:nvSpPr>
-          <p:cNvPr id="73" name="Rectangle 72"/>
+          <p:cNvPr id="74" name="Rectangle 73"/>
           <p:cNvSpPr/>
           <p:nvPr/>
         </p:nvSpPr>
@@ -7267,7 +7331,7 @@
       </p:sp>
       <p:sp>
         <p:nvSpPr>
-          <p:cNvPr id="74" name="Rectangle 73"/>
+          <p:cNvPr id="75" name="Rectangle 74"/>
           <p:cNvSpPr/>
           <p:nvPr/>
         </p:nvSpPr>
@@ -7311,7 +7375,7 @@
       </p:sp>
       <p:pic>
         <p:nvPicPr>
-          <p:cNvPr id="75" name="Picture 74" descr="group-logo-light.png"/>
+          <p:cNvPr id="76" name="Picture 75" descr="group-logo-light.png"/>
           <p:cNvPicPr>
             <a:picLocks noChangeAspect="1"/>
           </p:cNvPicPr>
@@ -7335,7 +7399,7 @@
       </p:pic>
       <p:sp>
         <p:nvSpPr>
-          <p:cNvPr id="76" name="Rectangle 75"/>
+          <p:cNvPr id="77" name="Rectangle 76"/>
           <p:cNvSpPr/>
           <p:nvPr/>
         </p:nvSpPr>
@@ -7431,7 +7495,7 @@
       </p:sp>
       <p:cxnSp>
         <p:nvCxnSpPr>
-          <p:cNvPr id="77" name="Connector 76"/>
+          <p:cNvPr id="78" name="Connector 77"/>
           <p:cNvCxnSpPr/>
           <p:nvPr/>
         </p:nvCxnSpPr>
@@ -7466,7 +7530,7 @@
       </p:cxnSp>
       <p:sp>
         <p:nvSpPr>
-          <p:cNvPr id="78" name="Rectangle 77"/>
+          <p:cNvPr id="79" name="Rectangle 78"/>
           <p:cNvSpPr/>
           <p:nvPr/>
         </p:nvSpPr>
@@ -7524,7 +7588,7 @@
       </p:sp>
       <p:sp>
         <p:nvSpPr>
-          <p:cNvPr id="79" name="Oval 78"/>
+          <p:cNvPr id="80" name="Oval 79"/>
           <p:cNvSpPr/>
           <p:nvPr/>
         </p:nvSpPr>
@@ -7568,7 +7632,7 @@
       </p:sp>
       <p:sp>
         <p:nvSpPr>
-          <p:cNvPr id="80" name="Rectangle 79"/>
+          <p:cNvPr id="81" name="Rectangle 80"/>
           <p:cNvSpPr/>
           <p:nvPr/>
         </p:nvSpPr>
@@ -7649,7 +7713,7 @@
       </p:sp>
       <p:sp>
         <p:nvSpPr>
-          <p:cNvPr id="81" name="Rectangle 80"/>
+          <p:cNvPr id="82" name="Rectangle 81"/>
           <p:cNvSpPr/>
           <p:nvPr/>
         </p:nvSpPr>
@@ -7707,7 +7771,7 @@
       </p:sp>
       <p:sp>
         <p:nvSpPr>
-          <p:cNvPr id="82" name="Oval 81"/>
+          <p:cNvPr id="83" name="Oval 82"/>
           <p:cNvSpPr/>
           <p:nvPr/>
         </p:nvSpPr>
@@ -7751,7 +7815,7 @@
       </p:sp>
       <p:sp>
         <p:nvSpPr>
-          <p:cNvPr id="83" name="Rectangle 82"/>
+          <p:cNvPr id="84" name="Rectangle 83"/>
           <p:cNvSpPr/>
           <p:nvPr/>
         </p:nvSpPr>
@@ -7832,7 +7896,7 @@
       </p:sp>
       <p:sp>
         <p:nvSpPr>
-          <p:cNvPr id="84" name="Rectangle 83"/>
+          <p:cNvPr id="85" name="Rectangle 84"/>
           <p:cNvSpPr/>
           <p:nvPr/>
         </p:nvSpPr>
@@ -7913,7 +7977,7 @@
       </p:sp>
       <p:sp>
         <p:nvSpPr>
-          <p:cNvPr id="85" name="Rectangle 84"/>
+          <p:cNvPr id="86" name="Rectangle 85"/>
           <p:cNvSpPr/>
           <p:nvPr/>
         </p:nvSpPr>
@@ -7971,7 +8035,7 @@
       </p:sp>
       <p:sp>
         <p:nvSpPr>
-          <p:cNvPr id="86" name="Oval 85"/>
+          <p:cNvPr id="87" name="Oval 86"/>
           <p:cNvSpPr/>
           <p:nvPr/>
         </p:nvSpPr>
@@ -8015,7 +8079,7 @@
       </p:sp>
       <p:sp>
         <p:nvSpPr>
-          <p:cNvPr id="87" name="Rectangle 86"/>
+          <p:cNvPr id="88" name="Rectangle 87"/>
           <p:cNvSpPr/>
           <p:nvPr/>
         </p:nvSpPr>
@@ -8096,7 +8160,7 @@
       </p:sp>
       <p:sp>
         <p:nvSpPr>
-          <p:cNvPr id="88" name="Rectangle 87"/>
+          <p:cNvPr id="89" name="Rectangle 88"/>
           <p:cNvSpPr/>
           <p:nvPr/>
         </p:nvSpPr>
@@ -8177,7 +8241,7 @@
       </p:sp>
       <p:sp>
         <p:nvSpPr>
-          <p:cNvPr id="89" name="Rectangle 88"/>
+          <p:cNvPr id="90" name="Rectangle 89"/>
           <p:cNvSpPr/>
           <p:nvPr/>
         </p:nvSpPr>

</xml_diff>

<commit_message>
Org chart: Harrison and Dylan part-time, full-time from August 2026; drop 'Trading as Freedom Global' from the header
Co-Authored-By: Claude Fable 5.1 <noreply@anthropic.com>
Claude-Session: https://claude.ai/code/session_01JcAmtPULFCnwMNNoCwcZpd
</commit_message>
<xml_diff>
--- a/application/org-chart/FFSL-Organisational-Structure-Sept-2026.pptx
+++ b/application/org-chart/FFSL-Organisational-Structure-Sept-2026.pptx
@@ -3267,7 +3267,7 @@
                 </a:solidFill>
                 <a:latin typeface="Segoe UI"/>
               </a:rPr>
-              <a:t>Company 13589467 · Unit 19, Pilsworth Industrial Estate, Bury, BL9 8RE · Trading as Freedom Global · A self-contained operating business with its own leadership, team and departments</a:t>
+              <a:t>Company 13589467 · Unit 19, Pilsworth Industrial Estate, Bury, BL9 8RE · A self-contained operating business with its own leadership, team and departments</a:t>
             </a:r>
           </a:p>
         </p:txBody>
@@ -5093,7 +5093,7 @@
             </a:avLst>
           </a:prstGeom>
           <a:solidFill>
-            <a:srgbClr val="111111"/>
+            <a:srgbClr val="8A8A85"/>
           </a:solidFill>
           <a:ln>
             <a:noFill/>
@@ -5133,7 +5133,7 @@
                 </a:solidFill>
                 <a:latin typeface="Segoe UI"/>
               </a:rPr>
-              <a:t>Full-time</a:t>
+              <a:t>Part-time</a:t>
             </a:r>
           </a:p>
         </p:txBody>
@@ -5280,7 +5280,7 @@
             </a:avLst>
           </a:prstGeom>
           <a:solidFill>
-            <a:srgbClr val="111111"/>
+            <a:srgbClr val="8A8A85"/>
           </a:solidFill>
           <a:ln>
             <a:noFill/>
@@ -5320,7 +5320,7 @@
                 </a:solidFill>
                 <a:latin typeface="Segoe UI"/>
               </a:rPr>
-              <a:t>Full-time</a:t>
+              <a:t>Part-time</a:t>
             </a:r>
           </a:p>
         </p:txBody>
@@ -5378,7 +5378,7 @@
                 </a:solidFill>
                 <a:latin typeface="Segoe UI"/>
               </a:rPr>
-              <a:t>Harrison and Dylan: full-time as subcontractors for the past six months, now moving into full-time employment within the business</a:t>
+              <a:t>Harrison and Dylan: part-time, moving into full-time employment within the business from August 2026</a:t>
             </a:r>
           </a:p>
         </p:txBody>
@@ -7324,7 +7324,7 @@
                 </a:solidFill>
                 <a:latin typeface="Segoe UI"/>
               </a:rPr>
-              <a:t>Prepared 6 September 2026 from the company staff register. Employment basis shown as at September 2026, including moves into direct employment now in progress.</a:t>
+              <a:t>Prepared 7 September 2026 from the company staff register. Employment basis shown as at September 2026, including moves into direct employment now in progress.</a:t>
             </a:r>
           </a:p>
         </p:txBody>

</xml_diff>